<commit_message>
Pitch: the researcher's problem gets its own slide after the doctor's ('Is this rise real? The answer takes weeks.'), 13 slides
</commit_message>
<xml_diff>
--- a/pitch/agar pitch.pptx
+++ b/pitch/agar pitch.pptx
@@ -17,9 +17,10 @@
     <p:sldId id="265" r:id="rId11"/>
     <p:sldId id="266" r:id="rId12"/>
     <p:sldId id="267" r:id="rId13"/>
+    <p:sldId id="268" r:id="rId14"/>
   </p:sldIdLst>
   <p:notesMasterIdLst>
-    <p:notesMasterId r:id="rId14"/>
+    <p:notesMasterId r:id="rId15"/>
   </p:notesMasterIdLst>
   <p:sldSz cx="9144000" cy="5143500"/>
   <p:notesSz cx="5143500" cy="9144000"/>
@@ -601,7 +602,7 @@
           <a:p>
             <a:r>
               <a:rPr lang="en-US" dirty="0"/>
-              <a:t>One feed goes in: the lab results, as HL7, the format the laboratory system already sends. Out of the same numbers come answers for everyone who acts on them. The doctor gets the right first antibiotic for this ward. Infection control gets clusters flagged, and the next step is sending them straight into their worklist. Researchers freeze a project at a date so the numbers never move under a paper, and export the data with R, Python and LaTeX methods to reproduce it. And the lab gets data checks on every batch, linked to THL’s regional trends.</a:t>
+              <a:t>An alert is only useful if you can trust it, so we measured ours. We planted 200 outbreaks of four patients into the three years of data. agar found 89 percent of them, a median of six days after the first case, at about four and a half alerts a year. We compared it with eight methods from the surveillance literature, and none of them beat it by the criteria we set before testing. All four test events in the data were caught, the ICU MRSA on day zero.</a:t>
             </a:r>
             <a:endParaRPr lang="en-US" dirty="0"/>
           </a:p>
@@ -689,7 +690,7 @@
           <a:p>
             <a:r>
               <a:rPr lang="en-US" dirty="0"/>
-              <a:t>A once-a-year report cannot keep up with bacteria that spread in days. agar gives every ward its own answer, every day, and tells you when something is wrong. Speed is a treatment. Thank you.</a:t>
+              <a:t>One feed goes in: the lab results, as HL7, the format the laboratory system already sends. Out of the same numbers come answers for everyone who acts on them. The doctor gets the right first antibiotic for this ward. Infection control gets clusters flagged, and the next step is sending them straight into their worklist. Researchers freeze a project at a date so the numbers never move under a paper, and export the data with R, Python and LaTeX methods to reproduce it. And the lab gets data checks on every batch, linked to THL’s regional trends.</a:t>
             </a:r>
             <a:endParaRPr lang="en-US" dirty="0"/>
           </a:p>
@@ -777,6 +778,94 @@
           <a:p>
             <a:r>
               <a:rPr lang="en-US" dirty="0"/>
+              <a:t>A once-a-year report cannot keep up with bacteria that spread in days. agar gives every ward its own answer, every day, and tells you when something is wrong. Speed is a treatment. Thank you.</a:t>
+            </a:r>
+            <a:endParaRPr lang="en-US" dirty="0"/>
+          </a:p>
+        </p:txBody>
+      </p:sp>
+      <p:sp>
+        <p:nvSpPr>
+          <p:cNvPr id="4" name="Slide Number Placeholder 3"/>
+          <p:cNvSpPr>
+            <a:spLocks noGrp="1"/>
+          </p:cNvSpPr>
+          <p:nvPr>
+            <p:ph type="sldNum" sz="quarter" idx="10"/>
+          </p:nvPr>
+        </p:nvSpPr>
+        <p:spPr/>
+        <p:txBody>
+          <a:bodyPr/>
+          <a:lstStyle/>
+          <a:p>
+            <a:fld id="{F7021451-1387-4CA6-816F-3879F97B5CBC}" type="slidenum">
+              <a:rPr lang="en-US"/>
+              <a:t>12</a:t>
+            </a:fld>
+            <a:endParaRPr lang="en-US"/>
+          </a:p>
+        </p:txBody>
+      </p:sp>
+    </p:spTree>
+    <p:extLst>
+      <p:ext uri="{BB962C8B-B14F-4D97-AF65-F5344CB8AC3E}">
+        <p14:creationId xmlns:p14="http://schemas.microsoft.com/office/powerpoint/2010/main" val="1024086991"/>
+      </p:ext>
+    </p:extLst>
+  </p:cSld>
+  <p:clrMapOvr>
+    <a:masterClrMapping/>
+  </p:clrMapOvr>
+</p:notes>
+</file>
+
+<file path=ppt/notesSlides/notesSlide13.xml><?xml version="1.0" encoding="utf-8"?>
+<p:notes xmlns:a="http://schemas.openxmlformats.org/drawingml/2006/main" xmlns:r="http://schemas.openxmlformats.org/officeDocument/2006/relationships" xmlns:p="http://schemas.openxmlformats.org/presentationml/2006/main">
+  <p:cSld>
+    <p:spTree>
+      <p:nvGrpSpPr>
+        <p:cNvPr id="1" name=""/>
+        <p:cNvGrpSpPr/>
+        <p:nvPr/>
+      </p:nvGrpSpPr>
+      <p:grpSpPr>
+        <a:xfrm>
+          <a:off x="0" y="0"/>
+          <a:ext cx="0" cy="0"/>
+          <a:chOff x="0" y="0"/>
+          <a:chExt cx="0" cy="0"/>
+        </a:xfrm>
+      </p:grpSpPr>
+      <p:sp>
+        <p:nvSpPr>
+          <p:cNvPr id="2" name="Slide Image Placeholder 1"/>
+          <p:cNvSpPr>
+            <a:spLocks noGrp="1" noRot="1" noChangeAspect="1"/>
+          </p:cNvSpPr>
+          <p:nvPr>
+            <p:ph type="sldImg"/>
+          </p:nvPr>
+        </p:nvSpPr>
+        <p:spPr/>
+      </p:sp>
+      <p:sp>
+        <p:nvSpPr>
+          <p:cNvPr id="3" name="Notes Placeholder 2"/>
+          <p:cNvSpPr>
+            <a:spLocks noGrp="1"/>
+          </p:cNvSpPr>
+          <p:nvPr>
+            <p:ph type="body" idx="1"/>
+          </p:nvPr>
+        </p:nvSpPr>
+        <p:spPr/>
+        <p:txBody>
+          <a:bodyPr/>
+          <a:lstStyle/>
+          <a:p>
+            <a:r>
+              <a:rPr lang="en-US" dirty="0"/>
               <a:t>Introduce the team.</a:t>
             </a:r>
             <a:endParaRPr lang="en-US" dirty="0"/>
@@ -800,7 +889,7 @@
           <a:p>
             <a:fld id="{F7021451-1387-4CA6-816F-3879F97B5CBC}" type="slidenum">
               <a:rPr lang="en-US"/>
-              <a:t>12</a:t>
+              <a:t>13</a:t>
             </a:fld>
             <a:endParaRPr lang="en-US"/>
           </a:p>
@@ -953,7 +1042,7 @@
           <a:p>
             <a:r>
               <a:rPr lang="en-US" dirty="0"/>
-              <a:t>What is the doctor’s guess based on? The resistance report. Tyks compiles it once a year, at hospital level. In the words of the challenge brief, too imprecise and infrequent. It cannot say what works on this ward this month, and it cannot see the bacterium spreading here right now.</a:t>
+              <a:t>The same week, a researcher at the lab sees resistance creeping up and asks the obvious question: is this rise real, or just noise? To answer it today, they export the data, clean it, count first isolates by hand and run the statistics in a spreadsheet. That takes weeks, and by then the question has moved on.</a:t>
             </a:r>
             <a:endParaRPr lang="en-US" dirty="0"/>
           </a:p>
@@ -1041,7 +1130,7 @@
           <a:p>
             <a:r>
               <a:rPr lang="en-US" dirty="0"/>
-              <a:t>And something is happening. On this same ward, seven patients have grown ESBL bacteria, the kind most common antibiotics fail against. Usual is 1.4. That is a cluster, maybe spreading from bed to bed. In a yearly hospital-wide average, seven patients on one ward disappear. That is why we built agar.</a:t>
+              <a:t>What is the doctor’s guess based on? The resistance report. Tyks compiles it once a year, at hospital level. In the words of the challenge brief, too imprecise and infrequent. It cannot say what works on this ward this month, and it cannot see the bacterium spreading here right now.</a:t>
             </a:r>
             <a:endParaRPr lang="en-US" dirty="0"/>
           </a:p>
@@ -1129,7 +1218,7 @@
           <a:p>
             <a:r>
               <a:rPr lang="en-US" dirty="0"/>
-              <a:t>agar. The right antibiotic for doctors, live alerts for infection control, and a notebook that does the statistics for researchers. One live feed of lab results behind all three.</a:t>
+              <a:t>And something is happening. On this same ward, seven patients have grown ESBL bacteria, the kind most common antibiotics fail against. Usual is 1.4. That is a cluster, maybe spreading from bed to bed. In a yearly hospital-wide average, seven patients on one ward disappear. That is why we built agar.</a:t>
             </a:r>
             <a:endParaRPr lang="en-US" dirty="0"/>
           </a:p>
@@ -1217,7 +1306,7 @@
           <a:p>
             <a:r>
               <a:rPr lang="en-US" dirty="0"/>
-              <a:t>This is agar on that Monday morning. The doctor picks the ward, the specimen and how severe the infection is. agar answers: start with mecillinam, it covers 97 percent of the likely bacteria on this ward, with ciprofloxacin and nitrofurantoin as alternatives. Every number shows the last four weeks next to the whole year, and how many patients it rests on.</a:t>
+              <a:t>agar. The right antibiotic for doctors, live alerts for infection control, and a notebook that does the statistics for researchers. One live feed of lab results behind all three.</a:t>
             </a:r>
             <a:endParaRPr lang="en-US" dirty="0"/>
           </a:p>
@@ -1305,7 +1394,7 @@
           <a:p>
             <a:r>
               <a:rPr lang="en-US" dirty="0"/>
-              <a:t>And the same cluster, seen by a researcher. The project is frozen on 30 April, so every number stays the same while the paper is written. The question, the slice of data and each analysis sit in one notebook, and every result comes with the Python or R code to reproduce it, and exports in one click.</a:t>
+              <a:t>This is agar on that Monday morning. The doctor picks the ward, the specimen and how severe the infection is. agar answers: start with mecillinam, it covers 97 percent of the likely bacteria on this ward, with ciprofloxacin and nitrofurantoin as alternatives. Every number shows the last four weeks next to the whole year, and how many patients it rests on.</a:t>
             </a:r>
             <a:endParaRPr lang="en-US" dirty="0"/>
           </a:p>
@@ -1393,7 +1482,7 @@
           <a:p>
             <a:r>
               <a:rPr lang="en-US" dirty="0"/>
-              <a:t>Play the two-minute film here. Don’t talk over it.</a:t>
+              <a:t>And the same cluster, seen by a researcher. The project is frozen on 30 April, so every number stays the same while the paper is written. The question, the slice of data and each analysis sit in one notebook, and every result comes with the Python or R code to reproduce it, and exports in one click.</a:t>
             </a:r>
             <a:endParaRPr lang="en-US" dirty="0"/>
           </a:p>
@@ -1481,7 +1570,7 @@
           <a:p>
             <a:r>
               <a:rPr lang="en-US" dirty="0"/>
-              <a:t>An alert is only useful if you can trust it, so we measured ours. We planted 200 outbreaks of four patients into the three years of data. agar found 89 percent of them, a median of six days after the first case, at about four and a half alerts a year. We compared it with eight methods from the surveillance literature, and none of them beat it by the criteria we set before testing. All four test events in the data were caught, the ICU MRSA on day zero.</a:t>
+              <a:t>Play the two-minute film here. Don’t talk over it.</a:t>
             </a:r>
             <a:endParaRPr lang="en-US" dirty="0"/>
           </a:p>
@@ -1898,6 +1987,55 @@
       </p:grpSpPr>
       <p:pic>
         <p:nvPicPr>
+          <p:cNvPr id="2" name="Image 0" descr="We measured it: 89 % of outbreaks found, 6 days to the first alert, 4 of 4 test events caught. 200 planted outbreaks, 8 methods compared.">    </p:cNvPr>
+          <p:cNvPicPr>
+            <a:picLocks noChangeAspect="1"/>
+          </p:cNvPicPr>
+          <p:nvPr/>
+        </p:nvPicPr>
+        <p:blipFill>
+          <a:blip r:embed="rId1"/>
+          <a:stretch>
+            <a:fillRect/>
+          </a:stretch>
+        </p:blipFill>
+        <p:spPr>
+          <a:xfrm>
+            <a:off x="0" y="0"/>
+            <a:ext cx="9144000" cy="5143500"/>
+          </a:xfrm>
+          <a:prstGeom prst="rect">
+            <a:avLst/>
+          </a:prstGeom>
+        </p:spPr>
+      </p:pic>
+    </p:spTree>
+  </p:cSld>
+  <p:clrMapOvr>
+    <a:masterClrMapping/>
+  </p:clrMapOvr>
+</p:sld>
+</file>
+
+<file path=ppt/slides/slide11.xml><?xml version="1.0" encoding="utf-8"?>
+<p:sld xmlns:a="http://schemas.openxmlformats.org/drawingml/2006/main" xmlns:r="http://schemas.openxmlformats.org/officeDocument/2006/relationships" xmlns:p="http://schemas.openxmlformats.org/presentationml/2006/main">
+  <p:cSld name="Slide 11">
+    <p:spTree>
+      <p:nvGrpSpPr>
+        <p:cNvPr id="1" name=""/>
+        <p:cNvGrpSpPr/>
+        <p:nvPr/>
+      </p:nvGrpSpPr>
+      <p:grpSpPr>
+        <a:xfrm>
+          <a:off x="0" y="0"/>
+          <a:ext cx="0" cy="0"/>
+          <a:chOff x="0" y="0"/>
+          <a:chExt cx="0" cy="0"/>
+        </a:xfrm>
+      </p:grpSpPr>
+      <p:pic>
+        <p:nvPicPr>
           <p:cNvPr id="2" name="Image 0" descr="One feed in, every reader out: Lab (HL7) to agar (live) to Doctor, Infection control, Researcher, Lab and region.">    </p:cNvPr>
           <p:cNvPicPr>
             <a:picLocks noChangeAspect="1"/>
@@ -1928,9 +2066,9 @@
 </p:sld>
 </file>
 
-<file path=ppt/slides/slide11.xml><?xml version="1.0" encoding="utf-8"?>
+<file path=ppt/slides/slide12.xml><?xml version="1.0" encoding="utf-8"?>
 <p:sld xmlns:a="http://schemas.openxmlformats.org/drawingml/2006/main" xmlns:r="http://schemas.openxmlformats.org/officeDocument/2006/relationships" xmlns:p="http://schemas.openxmlformats.org/presentationml/2006/main">
-  <p:cSld name="Slide 11">
+  <p:cSld name="Slide 12">
     <p:spTree>
       <p:nvGrpSpPr>
         <p:cNvPr id="1" name=""/>
@@ -1977,9 +2115,9 @@
 </p:sld>
 </file>
 
-<file path=ppt/slides/slide12.xml><?xml version="1.0" encoding="utf-8"?>
+<file path=ppt/slides/slide13.xml><?xml version="1.0" encoding="utf-8"?>
 <p:sld xmlns:a="http://schemas.openxmlformats.org/drawingml/2006/main" xmlns:r="http://schemas.openxmlformats.org/officeDocument/2006/relationships" xmlns:p="http://schemas.openxmlformats.org/presentationml/2006/main">
-  <p:cSld name="Slide 12">
+  <p:cSld name="Slide 13">
     <p:spTree>
       <p:nvGrpSpPr>
         <p:cNvPr id="1" name=""/>
@@ -2094,6 +2232,55 @@
       </p:grpSpPr>
       <p:pic>
         <p:nvPicPr>
+          <p:cNvPr id="2" name="Image 0" descr="Same week, the researcher: Is this rise real? The answer takes weeks. Export, clean, count, test. In spreadsheets.">    </p:cNvPr>
+          <p:cNvPicPr>
+            <a:picLocks noChangeAspect="1"/>
+          </p:cNvPicPr>
+          <p:nvPr/>
+        </p:nvPicPr>
+        <p:blipFill>
+          <a:blip r:embed="rId1"/>
+          <a:stretch>
+            <a:fillRect/>
+          </a:stretch>
+        </p:blipFill>
+        <p:spPr>
+          <a:xfrm>
+            <a:off x="0" y="0"/>
+            <a:ext cx="9144000" cy="5143500"/>
+          </a:xfrm>
+          <a:prstGeom prst="rect">
+            <a:avLst/>
+          </a:prstGeom>
+        </p:spPr>
+      </p:pic>
+    </p:spTree>
+  </p:cSld>
+  <p:clrMapOvr>
+    <a:masterClrMapping/>
+  </p:clrMapOvr>
+</p:sld>
+</file>
+
+<file path=ppt/slides/slide4.xml><?xml version="1.0" encoding="utf-8"?>
+<p:sld xmlns:a="http://schemas.openxmlformats.org/drawingml/2006/main" xmlns:r="http://schemas.openxmlformats.org/officeDocument/2006/relationships" xmlns:p="http://schemas.openxmlformats.org/presentationml/2006/main">
+  <p:cSld name="Slide 4">
+    <p:spTree>
+      <p:nvGrpSpPr>
+        <p:cNvPr id="1" name=""/>
+        <p:cNvGrpSpPr/>
+        <p:nvPr/>
+      </p:nvGrpSpPr>
+      <p:grpSpPr>
+        <a:xfrm>
+          <a:off x="0" y="0"/>
+          <a:ext cx="0" cy="0"/>
+          <a:chOff x="0" y="0"/>
+          <a:chExt cx="0" cy="0"/>
+        </a:xfrm>
+      </p:grpSpPr>
+      <p:pic>
+        <p:nvPicPr>
           <p:cNvPr id="2" name="Image 0" descr="Resistance reports come once a year. One number for the whole hospital. 'Too imprecise and infrequent.' The brief.">    </p:cNvPr>
           <p:cNvPicPr>
             <a:picLocks noChangeAspect="1"/>
@@ -2124,9 +2311,9 @@
 </p:sld>
 </file>
 
-<file path=ppt/slides/slide4.xml><?xml version="1.0" encoding="utf-8"?>
+<file path=ppt/slides/slide5.xml><?xml version="1.0" encoding="utf-8"?>
 <p:sld xmlns:a="http://schemas.openxmlformats.org/drawingml/2006/main" xmlns:r="http://schemas.openxmlformats.org/officeDocument/2006/relationships" xmlns:p="http://schemas.openxmlformats.org/presentationml/2006/main">
-  <p:cSld name="Slide 4">
+  <p:cSld name="Slide 5">
     <p:spTree>
       <p:nvGrpSpPr>
         <p:cNvPr id="1" name=""/>
@@ -2173,9 +2360,9 @@
 </p:sld>
 </file>
 
-<file path=ppt/slides/slide5.xml><?xml version="1.0" encoding="utf-8"?>
+<file path=ppt/slides/slide6.xml><?xml version="1.0" encoding="utf-8"?>
 <p:sld xmlns:a="http://schemas.openxmlformats.org/drawingml/2006/main" xmlns:r="http://schemas.openxmlformats.org/officeDocument/2006/relationships" xmlns:p="http://schemas.openxmlformats.org/presentationml/2006/main">
-  <p:cSld name="Slide 5">
+  <p:cSld name="Slide 6">
     <p:spTree>
       <p:nvGrpSpPr>
         <p:cNvPr id="1" name=""/>
@@ -2222,9 +2409,9 @@
 </p:sld>
 </file>
 
-<file path=ppt/slides/slide6.xml><?xml version="1.0" encoding="utf-8"?>
+<file path=ppt/slides/slide7.xml><?xml version="1.0" encoding="utf-8"?>
 <p:sld xmlns:a="http://schemas.openxmlformats.org/drawingml/2006/main" xmlns:r="http://schemas.openxmlformats.org/officeDocument/2006/relationships" xmlns:p="http://schemas.openxmlformats.org/presentationml/2006/main">
-  <p:cSld name="Slide 6">
+  <p:cSld name="Slide 7">
     <p:spTree>
       <p:nvGrpSpPr>
         <p:cNvPr id="1" name=""/>
@@ -2271,9 +2458,9 @@
 </p:sld>
 </file>
 
-<file path=ppt/slides/slide7.xml><?xml version="1.0" encoding="utf-8"?>
+<file path=ppt/slides/slide8.xml><?xml version="1.0" encoding="utf-8"?>
 <p:sld xmlns:a="http://schemas.openxmlformats.org/drawingml/2006/main" xmlns:r="http://schemas.openxmlformats.org/officeDocument/2006/relationships" xmlns:p="http://schemas.openxmlformats.org/presentationml/2006/main">
-  <p:cSld name="Slide 7">
+  <p:cSld name="Slide 8">
     <p:spTree>
       <p:nvGrpSpPr>
         <p:cNvPr id="1" name=""/>
@@ -2320,55 +2507,6 @@
 </p:sld>
 </file>
 
-<file path=ppt/slides/slide8.xml><?xml version="1.0" encoding="utf-8"?>
-<p:sld xmlns:a="http://schemas.openxmlformats.org/drawingml/2006/main" xmlns:r="http://schemas.openxmlformats.org/officeDocument/2006/relationships" xmlns:p="http://schemas.openxmlformats.org/presentationml/2006/main">
-  <p:cSld name="Slide 8">
-    <p:spTree>
-      <p:nvGrpSpPr>
-        <p:cNvPr id="1" name=""/>
-        <p:cNvGrpSpPr/>
-        <p:nvPr/>
-      </p:nvGrpSpPr>
-      <p:grpSpPr>
-        <a:xfrm>
-          <a:off x="0" y="0"/>
-          <a:ext cx="0" cy="0"/>
-          <a:chOff x="0" y="0"/>
-          <a:chExt cx="0" cy="0"/>
-        </a:xfrm>
-      </p:grpSpPr>
-      <p:pic>
-        <p:nvPicPr>
-          <p:cNvPr id="2" name="Image 0" descr="Demo, 2 minutes.">    </p:cNvPr>
-          <p:cNvPicPr>
-            <a:picLocks noChangeAspect="1"/>
-          </p:cNvPicPr>
-          <p:nvPr/>
-        </p:nvPicPr>
-        <p:blipFill>
-          <a:blip r:embed="rId1"/>
-          <a:stretch>
-            <a:fillRect/>
-          </a:stretch>
-        </p:blipFill>
-        <p:spPr>
-          <a:xfrm>
-            <a:off x="0" y="0"/>
-            <a:ext cx="9144000" cy="5143500"/>
-          </a:xfrm>
-          <a:prstGeom prst="rect">
-            <a:avLst/>
-          </a:prstGeom>
-        </p:spPr>
-      </p:pic>
-    </p:spTree>
-  </p:cSld>
-  <p:clrMapOvr>
-    <a:masterClrMapping/>
-  </p:clrMapOvr>
-</p:sld>
-</file>
-
 <file path=ppt/slides/slide9.xml><?xml version="1.0" encoding="utf-8"?>
 <p:sld xmlns:a="http://schemas.openxmlformats.org/drawingml/2006/main" xmlns:r="http://schemas.openxmlformats.org/officeDocument/2006/relationships" xmlns:p="http://schemas.openxmlformats.org/presentationml/2006/main">
   <p:cSld name="Slide 9">
@@ -2388,7 +2526,7 @@
       </p:grpSpPr>
       <p:pic>
         <p:nvPicPr>
-          <p:cNvPr id="2" name="Image 0" descr="We measured it: 89 % of outbreaks found, 6 days to the first alert, 4 of 4 test events caught. 200 planted outbreaks, 8 methods compared.">    </p:cNvPr>
+          <p:cNvPr id="2" name="Image 0" descr="Demo, 2 minutes.">    </p:cNvPr>
           <p:cNvPicPr>
             <a:picLocks noChangeAspect="1"/>
           </p:cNvPicPr>

</xml_diff>